<commit_message>
Refresh the report for the new rule and the real numbers
The gameplay slide still said "mark anything that could not be in a home", which
is the semantic rule the bystander change removed: with innocent objects of the
same sort standing in the room, "this does not belong here" is not decidable.
The slide now states the behavioural rule that replaced it, carries the six
remaining kinds, and records why the seventh was cut.

Assertion counts updated to what verify actually reports: 91 unit tests and 32
splat acceptance checks, 170 assertions in total.

Regenerated pptx (11 slides) and pdf (missingFonts: []).
</commit_message>
<xml_diff>
--- a/artifacts/report/FOREIGN-report.pptx
+++ b/artifacts/report/FOREIGN-report.pptx
@@ -5960,7 +5960,7 @@
                 </a:solidFill>
                 <a:latin typeface="Segoe UI"/>
               </a:rPr>
-              <a:t>标记任何不可能出现在一个家里的东西</a:t>
+              <a:t>只看它做什么，不看它是什么</a:t>
             </a:r>
           </a:p>
         </p:txBody>
@@ -6057,7 +6057,7 @@
         <p:spPr>
           <a:xfrm>
             <a:off x="658368" y="1792224"/>
-            <a:ext cx="6035040" cy="914400"/>
+            <a:ext cx="6035040" cy="1188720"/>
           </a:xfrm>
           <a:prstGeom prst="rect">
             <a:avLst/>
@@ -6076,7 +6076,7 @@
               </a:spcAft>
             </a:pPr>
             <a:r>
-              <a:rPr sz="1400" b="0">
+              <a:rPr sz="1300" b="0">
                 <a:solidFill>
                   <a:srgbClr val="9A9488"/>
                 </a:solidFill>
@@ -6092,13 +6092,29 @@
               </a:spcAft>
             </a:pPr>
             <a:r>
-              <a:rPr sz="1400" b="0">
+              <a:rPr sz="1300" b="0">
                 <a:solidFill>
                   <a:srgbClr val="9A9488"/>
                 </a:solidFill>
                 <a:latin typeface="Segoe UI"/>
               </a:rPr>
-              <a:t>这条约束砍掉了一整类设计：任何「和之前不一样」的东西都不能用。</a:t>
+              <a:t>甚至不需要判断这东西该不该在这儿：房间里本来就摆着同样奇怪的模型。</a:t>
+            </a:r>
+          </a:p>
+          <a:p>
+            <a:pPr algn="l">
+              <a:spcAft>
+                <a:spcPts val="800"/>
+              </a:spcAft>
+            </a:pPr>
+            <a:r>
+              <a:rPr sz="1300" b="0">
+                <a:solidFill>
+                  <a:srgbClr val="9A9488"/>
+                </a:solidFill>
+                <a:latin typeface="Segoe UI"/>
+              </a:rPr>
+              <a:t>凡是「和上一层不一样」才算的异常，都被砍掉了。</a:t>
             </a:r>
           </a:p>
         </p:txBody>
@@ -6111,7 +6127,7 @@
         </p:nvSpPr>
         <p:spPr>
           <a:xfrm>
-            <a:off x="658368" y="2834640"/>
+            <a:off x="658368" y="2971800"/>
             <a:ext cx="6035040" cy="365760"/>
           </a:xfrm>
           <a:prstGeom prst="rect">
@@ -6137,7 +6153,7 @@
                 </a:solidFill>
                 <a:latin typeface="Segoe UI"/>
               </a:rPr>
-              <a:t>因此删掉了「东西消失了」</a:t>
+              <a:t>所以：异常一定在「动」</a:t>
             </a:r>
           </a:p>
         </p:txBody>
@@ -6150,7 +6166,7 @@
         </p:nvSpPr>
         <p:spPr>
           <a:xfrm>
-            <a:off x="658368" y="3200400"/>
+            <a:off x="658368" y="3337560"/>
             <a:ext cx="6035040" cy="731520"/>
           </a:xfrm>
           <a:prstGeom prst="rect">
@@ -6176,7 +6192,7 @@
                 </a:solidFill>
                 <a:latin typeface="Segoe UI"/>
               </a:rPr>
-              <a:t>它只有在记得原样的前提下才成立。玩家第一次进房间，没有参照物。</a:t>
+              <a:t>在看你、浮起来、变了形、多了几个、倒过来、成群 —— 摆着不动的都是无辜的。</a:t>
             </a:r>
           </a:p>
         </p:txBody>
@@ -6189,7 +6205,7 @@
         </p:nvSpPr>
         <p:spPr>
           <a:xfrm>
-            <a:off x="658368" y="4114800"/>
+            <a:off x="658368" y="4160520"/>
             <a:ext cx="6035040" cy="365760"/>
           </a:xfrm>
           <a:prstGeom prst="rect">
@@ -6215,7 +6231,7 @@
                 </a:solidFill>
                 <a:latin typeface="Segoe UI"/>
               </a:rPr>
-              <a:t>现有 7 种异常</a:t>
+              <a:t>现有 6 种异常</a:t>
             </a:r>
           </a:p>
         </p:txBody>
@@ -6228,7 +6244,7 @@
         </p:nvSpPr>
         <p:spPr>
           <a:xfrm>
-            <a:off x="658368" y="4526280"/>
+            <a:off x="658368" y="4572000"/>
             <a:ext cx="1335024" cy="457200"/>
           </a:xfrm>
           <a:prstGeom prst="roundRect">
@@ -6274,7 +6290,7 @@
         </p:nvSpPr>
         <p:spPr>
           <a:xfrm>
-            <a:off x="658368" y="4617720"/>
+            <a:off x="658368" y="4663440"/>
             <a:ext cx="1335024" cy="292608"/>
           </a:xfrm>
           <a:prstGeom prst="rect">
@@ -6300,7 +6316,7 @@
                 </a:solidFill>
                 <a:latin typeface="Segoe UI"/>
               </a:rPr>
-              <a:t>异物闯入</a:t>
+              <a:t>注视</a:t>
             </a:r>
           </a:p>
         </p:txBody>
@@ -6313,7 +6329,7 @@
         </p:nvSpPr>
         <p:spPr>
           <a:xfrm>
-            <a:off x="2139696" y="4526280"/>
+            <a:off x="2139696" y="4572000"/>
             <a:ext cx="1335024" cy="457200"/>
           </a:xfrm>
           <a:prstGeom prst="roundRect">
@@ -6359,7 +6375,7 @@
         </p:nvSpPr>
         <p:spPr>
           <a:xfrm>
-            <a:off x="2139696" y="4617720"/>
+            <a:off x="2139696" y="4663440"/>
             <a:ext cx="1335024" cy="292608"/>
           </a:xfrm>
           <a:prstGeom prst="rect">
@@ -6385,7 +6401,7 @@
                 </a:solidFill>
                 <a:latin typeface="Segoe UI"/>
               </a:rPr>
-              <a:t>注视</a:t>
+              <a:t>悬浮</a:t>
             </a:r>
           </a:p>
         </p:txBody>
@@ -6398,7 +6414,7 @@
         </p:nvSpPr>
         <p:spPr>
           <a:xfrm>
-            <a:off x="3621024" y="4526280"/>
+            <a:off x="3621024" y="4572000"/>
             <a:ext cx="1335024" cy="457200"/>
           </a:xfrm>
           <a:prstGeom prst="roundRect">
@@ -6444,7 +6460,7 @@
         </p:nvSpPr>
         <p:spPr>
           <a:xfrm>
-            <a:off x="3621024" y="4617720"/>
+            <a:off x="3621024" y="4663440"/>
             <a:ext cx="1335024" cy="292608"/>
           </a:xfrm>
           <a:prstGeom prst="rect">
@@ -6470,7 +6486,7 @@
                 </a:solidFill>
                 <a:latin typeface="Segoe UI"/>
               </a:rPr>
-              <a:t>悬浮</a:t>
+              <a:t>变形</a:t>
             </a:r>
           </a:p>
         </p:txBody>
@@ -6483,7 +6499,7 @@
         </p:nvSpPr>
         <p:spPr>
           <a:xfrm>
-            <a:off x="5102352" y="4526280"/>
+            <a:off x="5102352" y="4572000"/>
             <a:ext cx="1335024" cy="457200"/>
           </a:xfrm>
           <a:prstGeom prst="roundRect">
@@ -6529,7 +6545,7 @@
         </p:nvSpPr>
         <p:spPr>
           <a:xfrm>
-            <a:off x="5102352" y="4617720"/>
+            <a:off x="5102352" y="4663440"/>
             <a:ext cx="1335024" cy="292608"/>
           </a:xfrm>
           <a:prstGeom prst="rect">
@@ -6555,7 +6571,7 @@
                 </a:solidFill>
                 <a:latin typeface="Segoe UI"/>
               </a:rPr>
-              <a:t>变形</a:t>
+              <a:t>复制</a:t>
             </a:r>
           </a:p>
         </p:txBody>
@@ -6568,7 +6584,7 @@
         </p:nvSpPr>
         <p:spPr>
           <a:xfrm>
-            <a:off x="658368" y="5093208"/>
+            <a:off x="658368" y="5138928"/>
             <a:ext cx="1335024" cy="457200"/>
           </a:xfrm>
           <a:prstGeom prst="roundRect">
@@ -6614,7 +6630,7 @@
         </p:nvSpPr>
         <p:spPr>
           <a:xfrm>
-            <a:off x="658368" y="5184648"/>
+            <a:off x="658368" y="5230368"/>
             <a:ext cx="1335024" cy="292608"/>
           </a:xfrm>
           <a:prstGeom prst="rect">
@@ -6640,7 +6656,7 @@
                 </a:solidFill>
                 <a:latin typeface="Segoe UI"/>
               </a:rPr>
-              <a:t>复制</a:t>
+              <a:t>倒挂</a:t>
             </a:r>
           </a:p>
         </p:txBody>
@@ -6653,7 +6669,7 @@
         </p:nvSpPr>
         <p:spPr>
           <a:xfrm>
-            <a:off x="2139696" y="5093208"/>
+            <a:off x="2139696" y="5138928"/>
             <a:ext cx="1335024" cy="457200"/>
           </a:xfrm>
           <a:prstGeom prst="roundRect">
@@ -6699,7 +6715,7 @@
         </p:nvSpPr>
         <p:spPr>
           <a:xfrm>
-            <a:off x="2139696" y="5184648"/>
+            <a:off x="2139696" y="5230368"/>
             <a:ext cx="1335024" cy="292608"/>
           </a:xfrm>
           <a:prstGeom prst="rect">
@@ -6725,67 +6741,21 @@
                 </a:solidFill>
                 <a:latin typeface="Segoe UI"/>
               </a:rPr>
-              <a:t>倒挂</a:t>
-            </a:r>
-          </a:p>
-        </p:txBody>
-      </p:sp>
-      <p:sp>
-        <p:nvSpPr>
-          <p:cNvPr id="23" name="Rounded Rectangle 22"/>
-          <p:cNvSpPr/>
-          <p:nvPr/>
-        </p:nvSpPr>
-        <p:spPr>
-          <a:xfrm>
-            <a:off x="3621024" y="5093208"/>
-            <a:ext cx="1335024" cy="457200"/>
-          </a:xfrm>
-          <a:prstGeom prst="roundRect">
-            <a:avLst/>
-          </a:prstGeom>
-          <a:solidFill>
-            <a:srgbClr val="161518"/>
-          </a:solidFill>
-          <a:ln>
-            <a:solidFill>
-              <a:srgbClr val="2C2A2E"/>
-            </a:solidFill>
-          </a:ln>
-          <a:effectLst/>
-        </p:spPr>
-        <p:style>
-          <a:lnRef idx="1">
-            <a:schemeClr val="accent1"/>
-          </a:lnRef>
-          <a:fillRef idx="3">
-            <a:schemeClr val="accent1"/>
-          </a:fillRef>
-          <a:effectRef idx="2">
-            <a:schemeClr val="accent1"/>
-          </a:effectRef>
-          <a:fontRef idx="minor">
-            <a:schemeClr val="lt1"/>
-          </a:fontRef>
-        </p:style>
-        <p:txBody>
-          <a:bodyPr rtlCol="0" anchor="ctr"/>
-          <a:lstStyle/>
-          <a:p>
-            <a:pPr algn="ctr"/>
-          </a:p>
-        </p:txBody>
-      </p:sp>
-      <p:sp>
-        <p:nvSpPr>
-          <p:cNvPr id="24" name="TextBox 23"/>
+              <a:t>成群</a:t>
+            </a:r>
+          </a:p>
+        </p:txBody>
+      </p:sp>
+      <p:sp>
+        <p:nvSpPr>
+          <p:cNvPr id="23" name="TextBox 22"/>
           <p:cNvSpPr txBox="1"/>
           <p:nvPr/>
         </p:nvSpPr>
         <p:spPr>
           <a:xfrm>
-            <a:off x="3621024" y="5184648"/>
-            <a:ext cx="1335024" cy="292608"/>
+            <a:off x="658368" y="5715000"/>
+            <a:ext cx="6035040" cy="457200"/>
           </a:xfrm>
           <a:prstGeom prst="rect">
             <a:avLst/>
@@ -6798,26 +6768,26 @@
           </a:bodyPr>
           <a:lstStyle/>
           <a:p>
-            <a:pPr algn="ctr">
+            <a:pPr algn="l">
               <a:spcAft>
                 <a:spcPts val="0"/>
               </a:spcAft>
             </a:pPr>
             <a:r>
-              <a:rPr sz="1200" b="0">
-                <a:solidFill>
-                  <a:srgbClr val="E8E4DC"/>
-                </a:solidFill>
-                <a:latin typeface="Segoe UI"/>
-              </a:rPr>
-              <a:t>成群</a:t>
-            </a:r>
-          </a:p>
-        </p:txBody>
-      </p:sp>
-      <p:sp>
-        <p:nvSpPr>
-          <p:cNvPr id="25" name="Rectangle 24"/>
+              <a:rPr sz="1000" b="0">
+                <a:solidFill>
+                  <a:srgbClr val="9A9488"/>
+                </a:solidFill>
+                <a:latin typeface="Segoe UI"/>
+              </a:rPr>
+              <a:t>删掉了「异物闯入」：房间里站着同类无辜物件之后，「它不该在这儿」就不再可判。</a:t>
+            </a:r>
+          </a:p>
+        </p:txBody>
+      </p:sp>
+      <p:sp>
+        <p:nvSpPr>
+          <p:cNvPr id="24" name="Rectangle 23"/>
           <p:cNvSpPr/>
           <p:nvPr/>
         </p:nvSpPr>
@@ -6861,7 +6831,7 @@
       </p:sp>
       <p:pic>
         <p:nvPicPr>
-          <p:cNvPr id="26" name="Picture 25" descr="10-horror-stare.png"/>
+          <p:cNvPr id="25" name="Picture 24" descr="10-horror-stare.png"/>
           <p:cNvPicPr>
             <a:picLocks noChangeAspect="1"/>
           </p:cNvPicPr>
@@ -9537,7 +9507,7 @@
                 </a:solidFill>
                 <a:latin typeface="Segoe UI"/>
               </a:rPr>
-              <a:t>npm run verify  =  类型检查 → 单测 → 构建 → 验收，共 161 项断言</a:t>
+              <a:t>npm run verify  =  类型检查 → 单测 → 构建 → 验收，共 170 项断言，全部通过</a:t>
             </a:r>
           </a:p>
         </p:txBody>
@@ -9622,7 +9592,7 @@
                 </a:solidFill>
                 <a:latin typeface="Segoe UI"/>
               </a:rPr>
-              <a:t>85</a:t>
+              <a:t>91</a:t>
             </a:r>
           </a:p>
         </p:txBody>
@@ -10118,7 +10088,7 @@
                 </a:solidFill>
                 <a:latin typeface="Segoe UI"/>
               </a:rPr>
-              <a:t>29</a:t>
+              <a:t>32</a:t>
             </a:r>
           </a:p>
         </p:txBody>

</xml_diff>

<commit_message>
docs: record why the room needed a normal, and refresh the report
The household-object change is the answer to a playtest note, so the reasoning
belongs next to the constraint that produced it rather than only in the commit
log. docs/06 gains a section covering:

* why "does this belong" had no truth value while bystanders and anomalies came
  from the same generated catalogue, and why `intrude` had been deleted rather
  than fixed;
* the split that replaces it (furniture is always innocent, an intruder is never
  furniture) and where that is asserted;
* why the thirteen props are offline GLB rather than runtime three.js — the
  Aholo scene rejects foreign objects, and this is the error that proved it;
* what floor 1 now teaches and why a floating chair beats a floating face.

Report numbers were stale in two places (170 -> 196 assertions, 91 -> 103 unit
tests, 32 -> 46 acceptance checks). The pptx and pdf are rebuilt from them.
</commit_message>
<xml_diff>
--- a/artifacts/report/FOREIGN-report.pptx
+++ b/artifacts/report/FOREIGN-report.pptx
@@ -8414,7 +8414,7 @@
                 </a:solidFill>
                 <a:latin typeface="Segoe UI"/>
               </a:rPr>
-              <a:t>不含任何渲染依赖，所以同一套关卡生成逻辑被两个后端使用，也被 85 个单测覆盖。</a:t>
+              <a:t>不含任何渲染依赖，所以同一套关卡生成逻辑被两个后端使用，也被 103 个单测覆盖。</a:t>
             </a:r>
           </a:p>
         </p:txBody>
@@ -9507,7 +9507,7 @@
                 </a:solidFill>
                 <a:latin typeface="Segoe UI"/>
               </a:rPr>
-              <a:t>npm run verify  =  类型检查 → 单测 → 构建 → 验收，共 170 项断言，全部通过</a:t>
+              <a:t>npm run verify  =  类型检查 → 单测 → 构建 → 验收，共 196 项断言，全部通过</a:t>
             </a:r>
           </a:p>
         </p:txBody>
@@ -9592,7 +9592,7 @@
                 </a:solidFill>
                 <a:latin typeface="Segoe UI"/>
               </a:rPr>
-              <a:t>91</a:t>
+              <a:t>103</a:t>
             </a:r>
           </a:p>
         </p:txBody>
@@ -10088,7 +10088,7 @@
                 </a:solidFill>
                 <a:latin typeface="Segoe UI"/>
               </a:rPr>
-              <a:t>32</a:t>
+              <a:t>46</a:t>
             </a:r>
           </a:p>
         </p:txBody>

</xml_diff>

<commit_message>
chore: put the demo stills under verification, and refresh the report
`demo:stills` now runs inside `npm run verify`. The check is cheap and it is the
only thing standing between a regenerated demo and one that is a photograph of a
wall: it caught exactly that on the first capture, where the centre standard
deviation was 3.6 against 38-72 for every real still. A demo that ships without
it can silently regress to showing nothing.

Slide 10 was rebuilt from the current state (the live deployment is verified 8/8
with 34 assets, and the video is 90 seconds rather than 78), and two rows that
overflowed their boxes by 4% were shortened until check-deck reports no
structural problems.
</commit_message>
<xml_diff>
--- a/artifacts/report/FOREIGN-report.pptx
+++ b/artifacts/report/FOREIGN-report.pptx
@@ -4065,7 +4065,7 @@
                 </a:solidFill>
                 <a:latin typeface="Segoe UI"/>
               </a:rPr>
-              <a:t>cyn-nya.github.io/foreign/ —— 在真实浏览器里实测可玩。</a:t>
+              <a:t>cyn-nya.github.io/foreign/ —— 线上实测 8/8，34 个资产全部就位。</a:t>
             </a:r>
           </a:p>
         </p:txBody>
@@ -4228,7 +4228,7 @@
                 </a:solidFill>
                 <a:latin typeface="Segoe UI"/>
               </a:rPr>
-              <a:t>78 秒真实游玩，清过第 1 层。机器无 GPU，帧率受限。</a:t>
+              <a:t>90 秒 720p。本机每秒不足一帧，录不了实机，故用真实截图合成。</a:t>
             </a:r>
           </a:p>
         </p:txBody>

</xml_diff>

<commit_message>
docs: the counts after the frame-rate work (125 unit tests, 224 assertions)
</commit_message>
<xml_diff>
--- a/artifacts/report/FOREIGN-report.pptx
+++ b/artifacts/report/FOREIGN-report.pptx
@@ -8414,7 +8414,7 @@
                 </a:solidFill>
                 <a:latin typeface="Segoe UI"/>
               </a:rPr>
-              <a:t>不含任何渲染依赖，所以同一套关卡生成逻辑被两个后端使用，也被 113 个单测覆盖。</a:t>
+              <a:t>不含任何渲染依赖，所以同一套关卡生成逻辑被两个后端使用，也被 125 个单测覆盖。</a:t>
             </a:r>
           </a:p>
         </p:txBody>
@@ -9507,7 +9507,7 @@
                 </a:solidFill>
                 <a:latin typeface="Segoe UI"/>
               </a:rPr>
-              <a:t>npm run verify  =  类型检查 → 单测 → 构建 → 验收，共 212 项断言，全部通过</a:t>
+              <a:t>npm run verify  =  类型检查 → 单测 → 构建 → 验收，共 224 项断言，全部通过</a:t>
             </a:r>
           </a:p>
         </p:txBody>
@@ -9592,7 +9592,7 @@
                 </a:solidFill>
                 <a:latin typeface="Segoe UI"/>
               </a:rPr>
-              <a:t>113</a:t>
+              <a:t>125</a:t>
             </a:r>
           </a:p>
         </p:txBody>

</xml_diff>

<commit_message>
docs: the report stops claiming a live URL, and covers the charge, the ghosts, the footsteps and the music
</commit_message>
<xml_diff>
--- a/artifacts/report/FOREIGN-report.pptx
+++ b/artifacts/report/FOREIGN-report.pptx
@@ -3674,8 +3674,8 @@
         </p:nvSpPr>
         <p:spPr>
           <a:xfrm>
-            <a:off x="4956048" y="1965960"/>
-            <a:ext cx="1097280" cy="292608"/>
+            <a:off x="4956048" y="1938528"/>
+            <a:ext cx="1097280" cy="347472"/>
           </a:xfrm>
           <a:prstGeom prst="rect">
             <a:avLst/>
@@ -3694,7 +3694,7 @@
               </a:spcAft>
             </a:pPr>
             <a:r>
-              <a:rPr sz="1200" b="1">
+              <a:rPr sz="1100" b="1">
                 <a:solidFill>
                   <a:srgbClr val="6FA86B"/>
                 </a:solidFill>
@@ -3713,8 +3713,8 @@
         </p:nvSpPr>
         <p:spPr>
           <a:xfrm>
-            <a:off x="6144768" y="1965960"/>
-            <a:ext cx="5114239" cy="329184"/>
+            <a:off x="6144768" y="1920240"/>
+            <a:ext cx="5114239" cy="402336"/>
           </a:xfrm>
           <a:prstGeom prst="rect">
             <a:avLst/>
@@ -3733,7 +3733,7 @@
               </a:spcAft>
             </a:pPr>
             <a:r>
-              <a:rPr sz="1100" b="0">
+              <a:rPr sz="950" b="0">
                 <a:solidFill>
                   <a:srgbClr val="9A9488"/>
                 </a:solidFill>
@@ -3837,8 +3837,8 @@
         </p:nvSpPr>
         <p:spPr>
           <a:xfrm>
-            <a:off x="4956048" y="2574036"/>
-            <a:ext cx="1097280" cy="292608"/>
+            <a:off x="4956048" y="2546604"/>
+            <a:ext cx="1097280" cy="347472"/>
           </a:xfrm>
           <a:prstGeom prst="rect">
             <a:avLst/>
@@ -3857,7 +3857,7 @@
               </a:spcAft>
             </a:pPr>
             <a:r>
-              <a:rPr sz="1200" b="1">
+              <a:rPr sz="1100" b="1">
                 <a:solidFill>
                   <a:srgbClr val="6FA86B"/>
                 </a:solidFill>
@@ -3876,8 +3876,8 @@
         </p:nvSpPr>
         <p:spPr>
           <a:xfrm>
-            <a:off x="6144768" y="2574036"/>
-            <a:ext cx="5114239" cy="329184"/>
+            <a:off x="6144768" y="2528316"/>
+            <a:ext cx="5114239" cy="402336"/>
           </a:xfrm>
           <a:prstGeom prst="rect">
             <a:avLst/>
@@ -3896,13 +3896,13 @@
               </a:spcAft>
             </a:pPr>
             <a:r>
-              <a:rPr sz="1100" b="0">
+              <a:rPr sz="950" b="0">
                 <a:solidFill>
                   <a:srgbClr val="9A9488"/>
                 </a:solidFill>
                 <a:latin typeface="Segoe UI"/>
               </a:rPr>
-              <a:t>异常类型 5 → 7 种；四种惊吓而非一种；黑暗与手电筒逐层递进。</a:t>
+              <a:t>异常类型 5 → 7 种；四种惊吓；冲锋；脚步与逐层加深的音乐床。</a:t>
             </a:r>
           </a:p>
         </p:txBody>
@@ -4000,8 +4000,8 @@
         </p:nvSpPr>
         <p:spPr>
           <a:xfrm>
-            <a:off x="4956048" y="3182112"/>
-            <a:ext cx="1097280" cy="292608"/>
+            <a:off x="4956048" y="3154680"/>
+            <a:ext cx="1097280" cy="347472"/>
           </a:xfrm>
           <a:prstGeom prst="rect">
             <a:avLst/>
@@ -4020,7 +4020,7 @@
               </a:spcAft>
             </a:pPr>
             <a:r>
-              <a:rPr sz="1200" b="1">
+              <a:rPr sz="1100" b="1">
                 <a:solidFill>
                   <a:srgbClr val="6FA86B"/>
                 </a:solidFill>
@@ -4039,8 +4039,8 @@
         </p:nvSpPr>
         <p:spPr>
           <a:xfrm>
-            <a:off x="6144768" y="3182112"/>
-            <a:ext cx="5114239" cy="329184"/>
+            <a:off x="6144768" y="3136392"/>
+            <a:ext cx="5114239" cy="402336"/>
           </a:xfrm>
           <a:prstGeom prst="rect">
             <a:avLst/>
@@ -4059,7 +4059,7 @@
               </a:spcAft>
             </a:pPr>
             <a:r>
-              <a:rPr sz="1100" b="0">
+              <a:rPr sz="950" b="0">
                 <a:solidFill>
                   <a:srgbClr val="9A9488"/>
                 </a:solidFill>
@@ -4163,8 +4163,8 @@
         </p:nvSpPr>
         <p:spPr>
           <a:xfrm>
-            <a:off x="4956048" y="3790188"/>
-            <a:ext cx="1097280" cy="292608"/>
+            <a:off x="4956048" y="3762756"/>
+            <a:ext cx="1097280" cy="347472"/>
           </a:xfrm>
           <a:prstGeom prst="rect">
             <a:avLst/>
@@ -4183,13 +4183,13 @@
               </a:spcAft>
             </a:pPr>
             <a:r>
-              <a:rPr sz="1200" b="1">
-                <a:solidFill>
-                  <a:srgbClr val="6FA86B"/>
-                </a:solidFill>
-                <a:latin typeface="Segoe UI"/>
-              </a:rPr>
-              <a:t>完成</a:t>
+              <a:rPr sz="1100" b="1">
+                <a:solidFill>
+                  <a:srgbClr val="D8A64A"/>
+                </a:solidFill>
+                <a:latin typeface="Segoe UI"/>
+              </a:rPr>
+              <a:t>未上线</a:t>
             </a:r>
           </a:p>
         </p:txBody>
@@ -4202,8 +4202,8 @@
         </p:nvSpPr>
         <p:spPr>
           <a:xfrm>
-            <a:off x="6144768" y="3790188"/>
-            <a:ext cx="5114239" cy="329184"/>
+            <a:off x="6144768" y="3744468"/>
+            <a:ext cx="5114239" cy="402336"/>
           </a:xfrm>
           <a:prstGeom prst="rect">
             <a:avLst/>
@@ -4222,13 +4222,13 @@
               </a:spcAft>
             </a:pPr>
             <a:r>
-              <a:rPr sz="1100" b="0">
+              <a:rPr sz="950" b="0">
                 <a:solidFill>
                   <a:srgbClr val="9A9488"/>
                 </a:solidFill>
                 <a:latin typeface="Segoe UI"/>
               </a:rPr>
-              <a:t>cyn-nya.github.io/foreign/ —— 线上实测 8/8，34 个资产全部就位。</a:t>
+              <a:t>gh-pages 已部署、本地验收 7/7；但仓库私有，Pages 开不了，线上仍 404。需把仓库改为 public。</a:t>
             </a:r>
           </a:p>
         </p:txBody>
@@ -4326,8 +4326,8 @@
         </p:nvSpPr>
         <p:spPr>
           <a:xfrm>
-            <a:off x="4956048" y="4398264"/>
-            <a:ext cx="1097280" cy="292608"/>
+            <a:off x="4956048" y="4370832"/>
+            <a:ext cx="1097280" cy="347472"/>
           </a:xfrm>
           <a:prstGeom prst="rect">
             <a:avLst/>
@@ -4346,7 +4346,7 @@
               </a:spcAft>
             </a:pPr>
             <a:r>
-              <a:rPr sz="1200" b="1">
+              <a:rPr sz="1100" b="1">
                 <a:solidFill>
                   <a:srgbClr val="6FA86B"/>
                 </a:solidFill>
@@ -4365,8 +4365,8 @@
         </p:nvSpPr>
         <p:spPr>
           <a:xfrm>
-            <a:off x="6144768" y="4398264"/>
-            <a:ext cx="5114239" cy="329184"/>
+            <a:off x="6144768" y="4352544"/>
+            <a:ext cx="5114239" cy="402336"/>
           </a:xfrm>
           <a:prstGeom prst="rect">
             <a:avLst/>
@@ -4385,7 +4385,7 @@
               </a:spcAft>
             </a:pPr>
             <a:r>
-              <a:rPr sz="1100" b="0">
+              <a:rPr sz="950" b="0">
                 <a:solidFill>
                   <a:srgbClr val="9A9488"/>
                 </a:solidFill>
@@ -4489,8 +4489,8 @@
         </p:nvSpPr>
         <p:spPr>
           <a:xfrm>
-            <a:off x="4956048" y="5006340"/>
-            <a:ext cx="1097280" cy="292608"/>
+            <a:off x="4956048" y="4978908"/>
+            <a:ext cx="1097280" cy="347472"/>
           </a:xfrm>
           <a:prstGeom prst="rect">
             <a:avLst/>
@@ -4509,13 +4509,13 @@
               </a:spcAft>
             </a:pPr>
             <a:r>
-              <a:rPr sz="1200" b="1">
-                <a:solidFill>
-                  <a:srgbClr val="C23B2E"/>
-                </a:solidFill>
-                <a:latin typeface="Segoe UI"/>
-              </a:rPr>
-              <a:t>待生成</a:t>
+              <a:rPr sz="1100" b="1">
+                <a:solidFill>
+                  <a:srgbClr val="6FA86B"/>
+                </a:solidFill>
+                <a:latin typeface="Segoe UI"/>
+              </a:rPr>
+              <a:t>已完成</a:t>
             </a:r>
           </a:p>
         </p:txBody>
@@ -4528,8 +4528,8 @@
         </p:nvSpPr>
         <p:spPr>
           <a:xfrm>
-            <a:off x="6144768" y="5006340"/>
-            <a:ext cx="5114239" cy="329184"/>
+            <a:off x="6144768" y="4960620"/>
+            <a:ext cx="5114239" cy="402336"/>
           </a:xfrm>
           <a:prstGeom prst="rect">
             <a:avLst/>
@@ -4548,13 +4548,13 @@
               </a:spcAft>
             </a:pPr>
             <a:r>
-              <a:rPr sz="1100" b="0">
+              <a:rPr sz="950" b="0">
                 <a:solidFill>
                   <a:srgbClr val="9A9488"/>
                 </a:solidFill>
                 <a:latin typeface="Segoe UI"/>
               </a:rPr>
-              <a:t>14/21 已由 Lux3D 生成，7 个仍是占位；接入已就绪，只缺额度。</a:t>
+              <a:t>55/55 全部由 Lux3D 生成：21 个异物、鬼影、伪人与冲刺体，13 件写实家具。</a:t>
             </a:r>
           </a:p>
         </p:txBody>
@@ -4652,8 +4652,8 @@
         </p:nvSpPr>
         <p:spPr>
           <a:xfrm>
-            <a:off x="4956048" y="5614416"/>
-            <a:ext cx="1097280" cy="292608"/>
+            <a:off x="4956048" y="5586984"/>
+            <a:ext cx="1097280" cy="347472"/>
           </a:xfrm>
           <a:prstGeom prst="rect">
             <a:avLst/>
@@ -4672,7 +4672,7 @@
               </a:spcAft>
             </a:pPr>
             <a:r>
-              <a:rPr sz="1200" b="1">
+              <a:rPr sz="1100" b="1">
                 <a:solidFill>
                   <a:srgbClr val="C23B2E"/>
                 </a:solidFill>
@@ -4691,8 +4691,8 @@
         </p:nvSpPr>
         <p:spPr>
           <a:xfrm>
-            <a:off x="6144768" y="5614416"/>
-            <a:ext cx="5114239" cy="329184"/>
+            <a:off x="6144768" y="5568696"/>
+            <a:ext cx="5114239" cy="402336"/>
           </a:xfrm>
           <a:prstGeom prst="rect">
             <a:avLst/>
@@ -4711,7 +4711,7 @@
               </a:spcAft>
             </a:pPr>
             <a:r>
-              <a:rPr sz="1100" b="0">
+              <a:rPr sz="950" b="0">
                 <a:solidFill>
                   <a:srgbClr val="9A9488"/>
                 </a:solidFill>
@@ -8577,7 +8577,7 @@
                 </a:solidFill>
                 <a:latin typeface="Segoe UI"/>
               </a:rPr>
-              <a:t>不含任何渲染依赖，所以同一套关卡生成逻辑被两个后端使用，也被 139 个单测覆盖。</a:t>
+              <a:t>不含任何渲染依赖，所以同一套关卡生成逻辑被两个后端使用，也被 168 个单测覆盖。</a:t>
             </a:r>
           </a:p>
         </p:txBody>
@@ -9670,7 +9670,7 @@
                 </a:solidFill>
                 <a:latin typeface="Segoe UI"/>
               </a:rPr>
-              <a:t>npm run verify  =  类型检查 → 单测 → 构建 → 验收，共 261 项断言，全部通过</a:t>
+              <a:t>npm run verify  =  类型检查 → 单测 → 构建 → 验收，共 306 项断言，全部通过</a:t>
             </a:r>
           </a:p>
         </p:txBody>
@@ -9755,7 +9755,7 @@
                 </a:solidFill>
                 <a:latin typeface="Segoe UI"/>
               </a:rPr>
-              <a:t>139</a:t>
+              <a:t>168</a:t>
             </a:r>
           </a:p>
         </p:txBody>
@@ -10127,7 +10127,7 @@
                 </a:solidFill>
                 <a:latin typeface="Segoe UI"/>
               </a:rPr>
-              <a:t>65</a:t>
+              <a:t>81</a:t>
             </a:r>
           </a:p>
         </p:txBody>
@@ -10926,7 +10926,7 @@
                 </a:solidFill>
                 <a:latin typeface="Segoe UI"/>
               </a:rPr>
-              <a:t>性能也要被量，包括量错再纠正</a:t>
+              <a:t>性能也要被量，而且量错了两次</a:t>
             </a:r>
           </a:p>
           <a:p>
@@ -10942,7 +10942,7 @@
                 </a:solidFill>
                 <a:latin typeface="Segoe UI"/>
               </a:rPr>
-              <a:t>先猜瓶颈在填充率，用只采几帧的方法「验证」为否 —— 方法不可靠。改用每档 90 秒重测：关掉重建后整帧只有 17 ms，重建占 99%，分辨率降 34%。先前的结论是错的，已纠正。</a:t>
+              <a:t>先猜瓶颈在 CPU 排序 —— 方法不可靠。改用每档 90 秒重测：重建占 99%，分辨率 0.40x 省 29%。但同一套方法又报了四个「有效旋钮」，重跑全部落空（基线自己漂了 60%）；工具这次拒绝出结论，四个都没进代码。</a:t>
             </a:r>
           </a:p>
         </p:txBody>
@@ -11312,7 +11312,7 @@
         <p:spPr>
           <a:xfrm>
             <a:off x="658368" y="1792224"/>
-            <a:ext cx="6400800" cy="969264"/>
+            <a:ext cx="6400800" cy="676656"/>
           </a:xfrm>
           <a:prstGeom prst="roundRect">
             <a:avLst/>
@@ -11357,8 +11357,8 @@
         </p:nvSpPr>
         <p:spPr>
           <a:xfrm>
-            <a:off x="877824" y="1883664"/>
-            <a:ext cx="5943600" cy="822960"/>
+            <a:off x="877824" y="1847088"/>
+            <a:ext cx="5943600" cy="585216"/>
           </a:xfrm>
           <a:prstGeom prst="rect">
             <a:avLst/>
@@ -11377,7 +11377,7 @@
               </a:spcAft>
             </a:pPr>
             <a:r>
-              <a:rPr sz="1500" b="1">
+              <a:rPr sz="1300" b="1">
                 <a:solidFill>
                   <a:srgbClr val="E8E4DC"/>
                 </a:solidFill>
@@ -11393,7 +11393,7 @@
               </a:spcAft>
             </a:pPr>
             <a:r>
-              <a:rPr sz="1100" b="0">
+              <a:rPr sz="950" b="0">
                 <a:solidFill>
                   <a:srgbClr val="9A9488"/>
                 </a:solidFill>
@@ -11413,8 +11413,8 @@
         </p:nvSpPr>
         <p:spPr>
           <a:xfrm>
-            <a:off x="658368" y="2852928"/>
-            <a:ext cx="6400800" cy="969264"/>
+            <a:off x="658368" y="2523744"/>
+            <a:ext cx="6400800" cy="676656"/>
           </a:xfrm>
           <a:prstGeom prst="roundRect">
             <a:avLst/>
@@ -11459,8 +11459,8 @@
         </p:nvSpPr>
         <p:spPr>
           <a:xfrm>
-            <a:off x="877824" y="2944368"/>
-            <a:ext cx="5943600" cy="822960"/>
+            <a:off x="877824" y="2578608"/>
+            <a:ext cx="5943600" cy="585216"/>
           </a:xfrm>
           <a:prstGeom prst="rect">
             <a:avLst/>
@@ -11479,7 +11479,7 @@
               </a:spcAft>
             </a:pPr>
             <a:r>
-              <a:rPr sz="1500" b="1">
+              <a:rPr sz="1300" b="1">
                 <a:solidFill>
                   <a:srgbClr val="E8E4DC"/>
                 </a:solidFill>
@@ -11495,7 +11495,7 @@
               </a:spcAft>
             </a:pPr>
             <a:r>
-              <a:rPr sz="1100" b="0">
+              <a:rPr sz="950" b="0">
                 <a:solidFill>
                   <a:srgbClr val="9A9488"/>
                 </a:solidFill>
@@ -11515,8 +11515,8 @@
         </p:nvSpPr>
         <p:spPr>
           <a:xfrm>
-            <a:off x="658368" y="3913632"/>
-            <a:ext cx="6400800" cy="969264"/>
+            <a:off x="658368" y="3255264"/>
+            <a:ext cx="6400800" cy="676656"/>
           </a:xfrm>
           <a:prstGeom prst="roundRect">
             <a:avLst/>
@@ -11561,8 +11561,8 @@
         </p:nvSpPr>
         <p:spPr>
           <a:xfrm>
-            <a:off x="877824" y="4005072"/>
-            <a:ext cx="5943600" cy="822960"/>
+            <a:off x="877824" y="3310128"/>
+            <a:ext cx="5943600" cy="585216"/>
           </a:xfrm>
           <a:prstGeom prst="rect">
             <a:avLst/>
@@ -11581,7 +11581,7 @@
               </a:spcAft>
             </a:pPr>
             <a:r>
-              <a:rPr sz="1500" b="1">
+              <a:rPr sz="1300" b="1">
                 <a:solidFill>
                   <a:srgbClr val="E8E4DC"/>
                 </a:solidFill>
@@ -11597,7 +11597,7 @@
               </a:spcAft>
             </a:pPr>
             <a:r>
-              <a:rPr sz="1100" b="0">
+              <a:rPr sz="950" b="0">
                 <a:solidFill>
                   <a:srgbClr val="9A9488"/>
                 </a:solidFill>
@@ -11617,8 +11617,8 @@
         </p:nvSpPr>
         <p:spPr>
           <a:xfrm>
-            <a:off x="658368" y="5102352"/>
-            <a:ext cx="6400800" cy="868680"/>
+            <a:off x="658368" y="3986784"/>
+            <a:ext cx="6400800" cy="676656"/>
           </a:xfrm>
           <a:prstGeom prst="roundRect">
             <a:avLst/>
@@ -11663,8 +11663,8 @@
         </p:nvSpPr>
         <p:spPr>
           <a:xfrm>
-            <a:off x="877824" y="5212080"/>
-            <a:ext cx="5943600" cy="658368"/>
+            <a:off x="877824" y="4041648"/>
+            <a:ext cx="5943600" cy="585216"/>
           </a:xfrm>
           <a:prstGeom prst="rect">
             <a:avLst/>
@@ -11683,6 +11683,210 @@
               </a:spcAft>
             </a:pPr>
             <a:r>
+              <a:rPr sz="1300" b="1">
+                <a:solidFill>
+                  <a:srgbClr val="E8E4DC"/>
+                </a:solidFill>
+                <a:latin typeface="Segoe UI"/>
+              </a:rPr>
+              <a:t>它会自己冲过来</a:t>
+            </a:r>
+          </a:p>
+          <a:p>
+            <a:pPr algn="l">
+              <a:spcAft>
+                <a:spcPts val="0"/>
+              </a:spcAft>
+            </a:pPr>
+            <a:r>
+              <a:rPr sz="950" b="0">
+                <a:solidFill>
+                  <a:srgbClr val="9A9488"/>
+                </a:solidFill>
+                <a:latin typeface="Segoe UI"/>
+              </a:rPr>
+              <a:t>第 3 层起，一个真实模型穿过房间向你逼近，窗口按层收紧（2200 ms → 1000 ms）。
+点鼠标解除；没解除就撞上你，并触发一次扑脸。这是唯一一个必须动手的机制。</a:t>
+            </a:r>
+          </a:p>
+        </p:txBody>
+      </p:sp>
+      <p:sp>
+        <p:nvSpPr>
+          <p:cNvPr id="15" name="Rounded Rectangle 14"/>
+          <p:cNvSpPr/>
+          <p:nvPr/>
+        </p:nvSpPr>
+        <p:spPr>
+          <a:xfrm>
+            <a:off x="658368" y="4718304"/>
+            <a:ext cx="6400800" cy="676656"/>
+          </a:xfrm>
+          <a:prstGeom prst="roundRect">
+            <a:avLst/>
+          </a:prstGeom>
+          <a:solidFill>
+            <a:srgbClr val="161518"/>
+          </a:solidFill>
+          <a:ln>
+            <a:solidFill>
+              <a:srgbClr val="2C2A2E"/>
+            </a:solidFill>
+          </a:ln>
+          <a:effectLst/>
+        </p:spPr>
+        <p:style>
+          <a:lnRef idx="1">
+            <a:schemeClr val="accent1"/>
+          </a:lnRef>
+          <a:fillRef idx="3">
+            <a:schemeClr val="accent1"/>
+          </a:fillRef>
+          <a:effectRef idx="2">
+            <a:schemeClr val="accent1"/>
+          </a:effectRef>
+          <a:fontRef idx="minor">
+            <a:schemeClr val="lt1"/>
+          </a:fontRef>
+        </p:style>
+        <p:txBody>
+          <a:bodyPr rtlCol="0" anchor="ctr"/>
+          <a:lstStyle/>
+          <a:p>
+            <a:pPr algn="ctr"/>
+          </a:p>
+        </p:txBody>
+      </p:sp>
+      <p:sp>
+        <p:nvSpPr>
+          <p:cNvPr id="16" name="TextBox 15"/>
+          <p:cNvSpPr txBox="1"/>
+          <p:nvPr/>
+        </p:nvSpPr>
+        <p:spPr>
+          <a:xfrm>
+            <a:off x="877824" y="4773168"/>
+            <a:ext cx="5943600" cy="585216"/>
+          </a:xfrm>
+          <a:prstGeom prst="rect">
+            <a:avLst/>
+          </a:prstGeom>
+          <a:noFill/>
+        </p:spPr>
+        <p:txBody>
+          <a:bodyPr wrap="square">
+            <a:spAutoFit/>
+          </a:bodyPr>
+          <a:lstStyle/>
+          <a:p>
+            <a:pPr algn="l">
+              <a:spcAft>
+                <a:spcPts val="300"/>
+              </a:spcAft>
+            </a:pPr>
+            <a:r>
+              <a:rPr sz="1300" b="1">
+                <a:solidFill>
+                  <a:srgbClr val="E8E4DC"/>
+                </a:solidFill>
+                <a:latin typeface="Segoe UI"/>
+              </a:rPr>
+              <a:t>脚步是距离，不是定时器</a:t>
+            </a:r>
+          </a:p>
+          <a:p>
+            <a:pPr algn="l">
+              <a:spcAft>
+                <a:spcPts val="0"/>
+              </a:spcAft>
+            </a:pPr>
+            <a:r>
+              <a:rPr sz="950" b="0">
+                <a:solidFill>
+                  <a:srgbClr val="9A9488"/>
+                </a:solidFill>
+                <a:latin typeface="Segoe UI"/>
+              </a:rPr>
+              <a:t>站在原地不动时一声不响（0.78 m 一步，且两步之间有下限间隔）。
+定时器版本会在你屏住呼吸的时候一直响 —— 那是恐怖游戏最不能犯的错。</a:t>
+            </a:r>
+          </a:p>
+        </p:txBody>
+      </p:sp>
+      <p:sp>
+        <p:nvSpPr>
+          <p:cNvPr id="17" name="Rounded Rectangle 16"/>
+          <p:cNvSpPr/>
+          <p:nvPr/>
+        </p:nvSpPr>
+        <p:spPr>
+          <a:xfrm>
+            <a:off x="658368" y="5504687"/>
+            <a:ext cx="6400800" cy="786384"/>
+          </a:xfrm>
+          <a:prstGeom prst="roundRect">
+            <a:avLst/>
+          </a:prstGeom>
+          <a:solidFill>
+            <a:srgbClr val="161518"/>
+          </a:solidFill>
+          <a:ln>
+            <a:solidFill>
+              <a:srgbClr val="2C2A2E"/>
+            </a:solidFill>
+          </a:ln>
+          <a:effectLst/>
+        </p:spPr>
+        <p:style>
+          <a:lnRef idx="1">
+            <a:schemeClr val="accent1"/>
+          </a:lnRef>
+          <a:fillRef idx="3">
+            <a:schemeClr val="accent1"/>
+          </a:fillRef>
+          <a:effectRef idx="2">
+            <a:schemeClr val="accent1"/>
+          </a:effectRef>
+          <a:fontRef idx="minor">
+            <a:schemeClr val="lt1"/>
+          </a:fontRef>
+        </p:style>
+        <p:txBody>
+          <a:bodyPr rtlCol="0" anchor="ctr"/>
+          <a:lstStyle/>
+          <a:p>
+            <a:pPr algn="ctr"/>
+          </a:p>
+        </p:txBody>
+      </p:sp>
+      <p:sp>
+        <p:nvSpPr>
+          <p:cNvPr id="18" name="TextBox 17"/>
+          <p:cNvSpPr txBox="1"/>
+          <p:nvPr/>
+        </p:nvSpPr>
+        <p:spPr>
+          <a:xfrm>
+            <a:off x="877824" y="5596128"/>
+            <a:ext cx="5943600" cy="621792"/>
+          </a:xfrm>
+          <a:prstGeom prst="rect">
+            <a:avLst/>
+          </a:prstGeom>
+          <a:noFill/>
+        </p:spPr>
+        <p:txBody>
+          <a:bodyPr wrap="square">
+            <a:spAutoFit/>
+          </a:bodyPr>
+          <a:lstStyle/>
+          <a:p>
+            <a:pPr algn="l">
+              <a:spcAft>
+                <a:spcPts val="300"/>
+              </a:spcAft>
+            </a:pPr>
+            <a:r>
               <a:rPr sz="1400" b="1">
                 <a:solidFill>
                   <a:srgbClr val="6FA86B"/>
@@ -11705,14 +11909,14 @@
                 </a:solidFill>
                 <a:latin typeface="Segoe UI"/>
               </a:rPr>
-              <a:t>读的是 AnalyserNode 的实际信号：7 m 处 gain 0.789、0.5 m 处 0.909，平均 RMS 近处响 21–31%。</a:t>
-            </a:r>
-          </a:p>
-        </p:txBody>
-      </p:sp>
-      <p:sp>
-        <p:nvSpPr>
-          <p:cNvPr id="15" name="Rectangle 14"/>
+              <a:t>读的是 AnalyserNode 的实际信号：7 m 处 gain 0.789、0.5 m 处 0.909，平均 RMS 近处响 21–31%。脚步则断言「走路有声、站着无声」两半。</a:t>
+            </a:r>
+          </a:p>
+        </p:txBody>
+      </p:sp>
+      <p:sp>
+        <p:nvSpPr>
+          <p:cNvPr id="19" name="Rectangle 18"/>
           <p:cNvSpPr/>
           <p:nvPr/>
         </p:nvSpPr>
@@ -11756,7 +11960,7 @@
       </p:sp>
       <p:pic>
         <p:nvPicPr>
-          <p:cNvPr id="16" name="Picture 15" descr="04-marked.png"/>
+          <p:cNvPr id="20" name="Picture 19" descr="04-marked.png"/>
           <p:cNvPicPr>
             <a:picLocks noChangeAspect="1"/>
           </p:cNvPicPr>

</xml_diff>

<commit_message>
docs: the report records the second occurrence of the floor-one symptom and how it was measured away
</commit_message>
<xml_diff>
--- a/artifacts/report/FOREIGN-report.pptx
+++ b/artifacts/report/FOREIGN-report.pptx
@@ -8577,7 +8577,7 @@
                 </a:solidFill>
                 <a:latin typeface="Segoe UI"/>
               </a:rPr>
-              <a:t>不含任何渲染依赖，所以同一套关卡生成逻辑被两个后端使用，也被 168 个单测覆盖。</a:t>
+              <a:t>不含任何渲染依赖，所以同一套关卡生成逻辑被两个后端使用，也被 172 个单测覆盖。</a:t>
             </a:r>
           </a:p>
         </p:txBody>
@@ -9670,7 +9670,7 @@
                 </a:solidFill>
                 <a:latin typeface="Segoe UI"/>
               </a:rPr>
-              <a:t>npm run verify  =  类型检查 → 单测 → 构建 → 验收，共 306 项断言，全部通过</a:t>
+              <a:t>npm run verify  =  类型检查 → 单测 → 构建 → 验收，共 311 项断言，全部通过</a:t>
             </a:r>
           </a:p>
         </p:txBody>
@@ -9755,7 +9755,7 @@
                 </a:solidFill>
                 <a:latin typeface="Segoe UI"/>
               </a:rPr>
-              <a:t>168</a:t>
+              <a:t>172</a:t>
             </a:r>
           </a:p>
         </p:txBody>
@@ -10127,7 +10127,7 @@
                 </a:solidFill>
                 <a:latin typeface="Segoe UI"/>
               </a:rPr>
-              <a:t>81</a:t>
+              <a:t>82</a:t>
             </a:r>
           </a:p>
         </p:txBody>
@@ -10551,8 +10551,8 @@
         </p:nvSpPr>
         <p:spPr>
           <a:xfrm>
-            <a:off x="658368" y="3401568"/>
-            <a:ext cx="6675120" cy="658368"/>
+            <a:off x="658368" y="2907792"/>
+            <a:ext cx="6675120" cy="640080"/>
           </a:xfrm>
           <a:prstGeom prst="roundRect">
             <a:avLst/>
@@ -10597,7 +10597,7 @@
         </p:nvSpPr>
         <p:spPr>
           <a:xfrm>
-            <a:off x="859536" y="3474720"/>
+            <a:off x="859536" y="2962656"/>
             <a:ext cx="6309360" cy="548640"/>
           </a:xfrm>
           <a:prstGeom prst="rect">
@@ -10617,7 +10617,7 @@
               </a:spcAft>
             </a:pPr>
             <a:r>
-              <a:rPr sz="1200" b="1">
+              <a:rPr sz="1150" b="1">
                 <a:solidFill>
                   <a:srgbClr val="E8E4DC"/>
                 </a:solidFill>
@@ -10633,7 +10633,7 @@
               </a:spcAft>
             </a:pPr>
             <a:r>
-              <a:rPr sz="1000" b="0">
+              <a:rPr sz="950" b="0">
                 <a:solidFill>
                   <a:srgbClr val="9A9488"/>
                 </a:solidFill>
@@ -10652,8 +10652,8 @@
         </p:nvSpPr>
         <p:spPr>
           <a:xfrm>
-            <a:off x="658368" y="4133088"/>
-            <a:ext cx="6675120" cy="658368"/>
+            <a:off x="658368" y="3602736"/>
+            <a:ext cx="6675120" cy="640080"/>
           </a:xfrm>
           <a:prstGeom prst="roundRect">
             <a:avLst/>
@@ -10698,7 +10698,7 @@
         </p:nvSpPr>
         <p:spPr>
           <a:xfrm>
-            <a:off x="859536" y="4206240"/>
+            <a:off x="859536" y="3657600"/>
             <a:ext cx="6309360" cy="548640"/>
           </a:xfrm>
           <a:prstGeom prst="rect">
@@ -10718,7 +10718,7 @@
               </a:spcAft>
             </a:pPr>
             <a:r>
-              <a:rPr sz="1200" b="1">
+              <a:rPr sz="1150" b="1">
                 <a:solidFill>
                   <a:srgbClr val="E8E4DC"/>
                 </a:solidFill>
@@ -10734,7 +10734,7 @@
               </a:spcAft>
             </a:pPr>
             <a:r>
-              <a:rPr sz="1000" b="0">
+              <a:rPr sz="950" b="0">
                 <a:solidFill>
                   <a:srgbClr val="9A9488"/>
                 </a:solidFill>
@@ -10753,8 +10753,8 @@
         </p:nvSpPr>
         <p:spPr>
           <a:xfrm>
-            <a:off x="658368" y="4864608"/>
-            <a:ext cx="6675120" cy="658368"/>
+            <a:off x="658368" y="4297680"/>
+            <a:ext cx="6675120" cy="640080"/>
           </a:xfrm>
           <a:prstGeom prst="roundRect">
             <a:avLst/>
@@ -10799,7 +10799,7 @@
         </p:nvSpPr>
         <p:spPr>
           <a:xfrm>
-            <a:off x="859536" y="4937760"/>
+            <a:off x="859536" y="4352544"/>
             <a:ext cx="6309360" cy="548640"/>
           </a:xfrm>
           <a:prstGeom prst="rect">
@@ -10819,7 +10819,7 @@
               </a:spcAft>
             </a:pPr>
             <a:r>
-              <a:rPr sz="1200" b="1">
+              <a:rPr sz="1150" b="1">
                 <a:solidFill>
                   <a:srgbClr val="E8E4DC"/>
                 </a:solidFill>
@@ -10835,7 +10835,7 @@
               </a:spcAft>
             </a:pPr>
             <a:r>
-              <a:rPr sz="1000" b="0">
+              <a:rPr sz="950" b="0">
                 <a:solidFill>
                   <a:srgbClr val="9A9488"/>
                 </a:solidFill>
@@ -10854,8 +10854,8 @@
         </p:nvSpPr>
         <p:spPr>
           <a:xfrm>
-            <a:off x="658368" y="5596128"/>
-            <a:ext cx="6675120" cy="658368"/>
+            <a:off x="658368" y="4992624"/>
+            <a:ext cx="6675120" cy="640080"/>
           </a:xfrm>
           <a:prstGeom prst="roundRect">
             <a:avLst/>
@@ -10900,7 +10900,7 @@
         </p:nvSpPr>
         <p:spPr>
           <a:xfrm>
-            <a:off x="859536" y="5669280"/>
+            <a:off x="859536" y="5047488"/>
             <a:ext cx="6309360" cy="548640"/>
           </a:xfrm>
           <a:prstGeom prst="rect">
@@ -10920,12 +10920,113 @@
               </a:spcAft>
             </a:pPr>
             <a:r>
-              <a:rPr sz="1200" b="1">
+              <a:rPr sz="1150" b="1">
                 <a:solidFill>
                   <a:srgbClr val="E8E4DC"/>
                 </a:solidFill>
                 <a:latin typeface="Segoe UI"/>
               </a:rPr>
+              <a:t>同一症状出现两次，就该去量而不是再猜</a:t>
+            </a:r>
+          </a:p>
+          <a:p>
+            <a:pPr algn="l">
+              <a:spcAft>
+                <a:spcPts val="0"/>
+              </a:spcAft>
+            </a:pPr>
+            <a:r>
+              <a:rPr sz="950" b="0">
+                <a:solidFill>
+                  <a:srgbClr val="9A9488"/>
+                </a:solidFill>
+                <a:latin typeface="Segoe UI"/>
+              </a:rPr>
+              <a:t>玩家两遍都说「第一关走完了没找到东西」。四个假设全被测量否掉，最后指向 height：渲染器当它是缩放目标所以永远对，过滤器却当它是真实尺寸。</a:t>
+            </a:r>
+          </a:p>
+        </p:txBody>
+      </p:sp>
+      <p:sp>
+        <p:nvSpPr>
+          <p:cNvPr id="37" name="Rounded Rectangle 36"/>
+          <p:cNvSpPr/>
+          <p:nvPr/>
+        </p:nvSpPr>
+        <p:spPr>
+          <a:xfrm>
+            <a:off x="658368" y="5687568"/>
+            <a:ext cx="6675120" cy="640080"/>
+          </a:xfrm>
+          <a:prstGeom prst="roundRect">
+            <a:avLst/>
+          </a:prstGeom>
+          <a:solidFill>
+            <a:srgbClr val="161518"/>
+          </a:solidFill>
+          <a:ln>
+            <a:solidFill>
+              <a:srgbClr val="2C2A2E"/>
+            </a:solidFill>
+          </a:ln>
+          <a:effectLst/>
+        </p:spPr>
+        <p:style>
+          <a:lnRef idx="1">
+            <a:schemeClr val="accent1"/>
+          </a:lnRef>
+          <a:fillRef idx="3">
+            <a:schemeClr val="accent1"/>
+          </a:fillRef>
+          <a:effectRef idx="2">
+            <a:schemeClr val="accent1"/>
+          </a:effectRef>
+          <a:fontRef idx="minor">
+            <a:schemeClr val="lt1"/>
+          </a:fontRef>
+        </p:style>
+        <p:txBody>
+          <a:bodyPr rtlCol="0" anchor="ctr"/>
+          <a:lstStyle/>
+          <a:p>
+            <a:pPr algn="ctr"/>
+          </a:p>
+        </p:txBody>
+      </p:sp>
+      <p:sp>
+        <p:nvSpPr>
+          <p:cNvPr id="38" name="TextBox 37"/>
+          <p:cNvSpPr txBox="1"/>
+          <p:nvPr/>
+        </p:nvSpPr>
+        <p:spPr>
+          <a:xfrm>
+            <a:off x="859536" y="5742432"/>
+            <a:ext cx="6309360" cy="548640"/>
+          </a:xfrm>
+          <a:prstGeom prst="rect">
+            <a:avLst/>
+          </a:prstGeom>
+          <a:noFill/>
+        </p:spPr>
+        <p:txBody>
+          <a:bodyPr wrap="square">
+            <a:spAutoFit/>
+          </a:bodyPr>
+          <a:lstStyle/>
+          <a:p>
+            <a:pPr algn="l">
+              <a:spcAft>
+                <a:spcPts val="200"/>
+              </a:spcAft>
+            </a:pPr>
+            <a:r>
+              <a:rPr sz="1150" b="1">
+                <a:solidFill>
+                  <a:srgbClr val="E8E4DC"/>
+                </a:solidFill>
+                <a:latin typeface="Segoe UI"/>
+              </a:rPr>
               <a:t>性能也要被量，而且量错了两次</a:t>
             </a:r>
           </a:p>
@@ -10936,7 +11037,7 @@
               </a:spcAft>
             </a:pPr>
             <a:r>
-              <a:rPr sz="1000" b="0">
+              <a:rPr sz="950" b="0">
                 <a:solidFill>
                   <a:srgbClr val="9A9488"/>
                 </a:solidFill>
@@ -10949,7 +11050,7 @@
       </p:sp>
       <p:sp>
         <p:nvSpPr>
-          <p:cNvPr id="37" name="Rounded Rectangle 36"/>
+          <p:cNvPr id="39" name="Rounded Rectangle 38"/>
           <p:cNvSpPr/>
           <p:nvPr/>
         </p:nvSpPr>
@@ -10995,7 +11096,7 @@
       </p:sp>
       <p:sp>
         <p:nvSpPr>
-          <p:cNvPr id="38" name="TextBox 37"/>
+          <p:cNvPr id="40" name="TextBox 39"/>
           <p:cNvSpPr txBox="1"/>
           <p:nvPr/>
         </p:nvSpPr>

</xml_diff>

<commit_message>
docs: the report records that the first twenty seconds were a performance bug too
</commit_message>
<xml_diff>
--- a/artifacts/report/FOREIGN-report.pptx
+++ b/artifacts/report/FOREIGN-report.pptx
@@ -10551,8 +10551,8 @@
         </p:nvSpPr>
         <p:spPr>
           <a:xfrm>
-            <a:off x="658368" y="2907792"/>
-            <a:ext cx="6675120" cy="640080"/>
+            <a:off x="658368" y="2798064"/>
+            <a:ext cx="6675120" cy="566928"/>
           </a:xfrm>
           <a:prstGeom prst="roundRect">
             <a:avLst/>
@@ -10597,8 +10597,8 @@
         </p:nvSpPr>
         <p:spPr>
           <a:xfrm>
-            <a:off x="859536" y="2962656"/>
-            <a:ext cx="6309360" cy="548640"/>
+            <a:off x="859536" y="2834640"/>
+            <a:ext cx="6309360" cy="512064"/>
           </a:xfrm>
           <a:prstGeom prst="rect">
             <a:avLst/>
@@ -10613,11 +10613,11 @@
           <a:p>
             <a:pPr algn="l">
               <a:spcAft>
-                <a:spcPts val="200"/>
-              </a:spcAft>
-            </a:pPr>
-            <a:r>
-              <a:rPr sz="1150" b="1">
+                <a:spcPts val="100"/>
+              </a:spcAft>
+            </a:pPr>
+            <a:r>
+              <a:rPr sz="1100" b="1">
                 <a:solidFill>
                   <a:srgbClr val="E8E4DC"/>
                 </a:solidFill>
@@ -10633,7 +10633,7 @@
               </a:spcAft>
             </a:pPr>
             <a:r>
-              <a:rPr sz="950" b="0">
+              <a:rPr sz="900" b="0">
                 <a:solidFill>
                   <a:srgbClr val="9A9488"/>
                 </a:solidFill>
@@ -10652,8 +10652,8 @@
         </p:nvSpPr>
         <p:spPr>
           <a:xfrm>
-            <a:off x="658368" y="3602736"/>
-            <a:ext cx="6675120" cy="640080"/>
+            <a:off x="658368" y="3419856"/>
+            <a:ext cx="6675120" cy="566928"/>
           </a:xfrm>
           <a:prstGeom prst="roundRect">
             <a:avLst/>
@@ -10698,8 +10698,8 @@
         </p:nvSpPr>
         <p:spPr>
           <a:xfrm>
-            <a:off x="859536" y="3657600"/>
-            <a:ext cx="6309360" cy="548640"/>
+            <a:off x="859536" y="3456432"/>
+            <a:ext cx="6309360" cy="512064"/>
           </a:xfrm>
           <a:prstGeom prst="rect">
             <a:avLst/>
@@ -10714,11 +10714,11 @@
           <a:p>
             <a:pPr algn="l">
               <a:spcAft>
-                <a:spcPts val="200"/>
-              </a:spcAft>
-            </a:pPr>
-            <a:r>
-              <a:rPr sz="1150" b="1">
+                <a:spcPts val="100"/>
+              </a:spcAft>
+            </a:pPr>
+            <a:r>
+              <a:rPr sz="1100" b="1">
                 <a:solidFill>
                   <a:srgbClr val="E8E4DC"/>
                 </a:solidFill>
@@ -10734,7 +10734,7 @@
               </a:spcAft>
             </a:pPr>
             <a:r>
-              <a:rPr sz="950" b="0">
+              <a:rPr sz="900" b="0">
                 <a:solidFill>
                   <a:srgbClr val="9A9488"/>
                 </a:solidFill>
@@ -10753,8 +10753,8 @@
         </p:nvSpPr>
         <p:spPr>
           <a:xfrm>
-            <a:off x="658368" y="4297680"/>
-            <a:ext cx="6675120" cy="640080"/>
+            <a:off x="658368" y="4041648"/>
+            <a:ext cx="6675120" cy="566928"/>
           </a:xfrm>
           <a:prstGeom prst="roundRect">
             <a:avLst/>
@@ -10799,8 +10799,8 @@
         </p:nvSpPr>
         <p:spPr>
           <a:xfrm>
-            <a:off x="859536" y="4352544"/>
-            <a:ext cx="6309360" cy="548640"/>
+            <a:off x="859536" y="4078224"/>
+            <a:ext cx="6309360" cy="512064"/>
           </a:xfrm>
           <a:prstGeom prst="rect">
             <a:avLst/>
@@ -10815,11 +10815,11 @@
           <a:p>
             <a:pPr algn="l">
               <a:spcAft>
-                <a:spcPts val="200"/>
-              </a:spcAft>
-            </a:pPr>
-            <a:r>
-              <a:rPr sz="1150" b="1">
+                <a:spcPts val="100"/>
+              </a:spcAft>
+            </a:pPr>
+            <a:r>
+              <a:rPr sz="1100" b="1">
                 <a:solidFill>
                   <a:srgbClr val="E8E4DC"/>
                 </a:solidFill>
@@ -10835,7 +10835,7 @@
               </a:spcAft>
             </a:pPr>
             <a:r>
-              <a:rPr sz="950" b="0">
+              <a:rPr sz="900" b="0">
                 <a:solidFill>
                   <a:srgbClr val="9A9488"/>
                 </a:solidFill>
@@ -10854,8 +10854,8 @@
         </p:nvSpPr>
         <p:spPr>
           <a:xfrm>
-            <a:off x="658368" y="4992624"/>
-            <a:ext cx="6675120" cy="640080"/>
+            <a:off x="658368" y="4663440"/>
+            <a:ext cx="6675120" cy="566928"/>
           </a:xfrm>
           <a:prstGeom prst="roundRect">
             <a:avLst/>
@@ -10900,8 +10900,8 @@
         </p:nvSpPr>
         <p:spPr>
           <a:xfrm>
-            <a:off x="859536" y="5047488"/>
-            <a:ext cx="6309360" cy="548640"/>
+            <a:off x="859536" y="4700016"/>
+            <a:ext cx="6309360" cy="512064"/>
           </a:xfrm>
           <a:prstGeom prst="rect">
             <a:avLst/>
@@ -10916,11 +10916,11 @@
           <a:p>
             <a:pPr algn="l">
               <a:spcAft>
-                <a:spcPts val="200"/>
-              </a:spcAft>
-            </a:pPr>
-            <a:r>
-              <a:rPr sz="1150" b="1">
+                <a:spcPts val="100"/>
+              </a:spcAft>
+            </a:pPr>
+            <a:r>
+              <a:rPr sz="1100" b="1">
                 <a:solidFill>
                   <a:srgbClr val="E8E4DC"/>
                 </a:solidFill>
@@ -10936,7 +10936,7 @@
               </a:spcAft>
             </a:pPr>
             <a:r>
-              <a:rPr sz="950" b="0">
+              <a:rPr sz="900" b="0">
                 <a:solidFill>
                   <a:srgbClr val="9A9488"/>
                 </a:solidFill>
@@ -10955,8 +10955,8 @@
         </p:nvSpPr>
         <p:spPr>
           <a:xfrm>
-            <a:off x="658368" y="5687568"/>
-            <a:ext cx="6675120" cy="640080"/>
+            <a:off x="658368" y="5285232"/>
+            <a:ext cx="6675120" cy="566928"/>
           </a:xfrm>
           <a:prstGeom prst="roundRect">
             <a:avLst/>
@@ -11001,8 +11001,8 @@
         </p:nvSpPr>
         <p:spPr>
           <a:xfrm>
-            <a:off x="859536" y="5742432"/>
-            <a:ext cx="6309360" cy="548640"/>
+            <a:off x="859536" y="5321808"/>
+            <a:ext cx="6309360" cy="512064"/>
           </a:xfrm>
           <a:prstGeom prst="rect">
             <a:avLst/>
@@ -11017,11 +11017,11 @@
           <a:p>
             <a:pPr algn="l">
               <a:spcAft>
-                <a:spcPts val="200"/>
-              </a:spcAft>
-            </a:pPr>
-            <a:r>
-              <a:rPr sz="1150" b="1">
+                <a:spcPts val="100"/>
+              </a:spcAft>
+            </a:pPr>
+            <a:r>
+              <a:rPr sz="1100" b="1">
                 <a:solidFill>
                   <a:srgbClr val="E8E4DC"/>
                 </a:solidFill>
@@ -11037,7 +11037,7 @@
               </a:spcAft>
             </a:pPr>
             <a:r>
-              <a:rPr sz="950" b="0">
+              <a:rPr sz="900" b="0">
                 <a:solidFill>
                   <a:srgbClr val="9A9488"/>
                 </a:solidFill>
@@ -11051,6 +11051,107 @@
       <p:sp>
         <p:nvSpPr>
           <p:cNvPr id="39" name="Rounded Rectangle 38"/>
+          <p:cNvSpPr/>
+          <p:nvPr/>
+        </p:nvSpPr>
+        <p:spPr>
+          <a:xfrm>
+            <a:off x="658368" y="5907024"/>
+            <a:ext cx="6675120" cy="566928"/>
+          </a:xfrm>
+          <a:prstGeom prst="roundRect">
+            <a:avLst/>
+          </a:prstGeom>
+          <a:solidFill>
+            <a:srgbClr val="161518"/>
+          </a:solidFill>
+          <a:ln>
+            <a:solidFill>
+              <a:srgbClr val="2C2A2E"/>
+            </a:solidFill>
+          </a:ln>
+          <a:effectLst/>
+        </p:spPr>
+        <p:style>
+          <a:lnRef idx="1">
+            <a:schemeClr val="accent1"/>
+          </a:lnRef>
+          <a:fillRef idx="3">
+            <a:schemeClr val="accent1"/>
+          </a:fillRef>
+          <a:effectRef idx="2">
+            <a:schemeClr val="accent1"/>
+          </a:effectRef>
+          <a:fontRef idx="minor">
+            <a:schemeClr val="lt1"/>
+          </a:fontRef>
+        </p:style>
+        <p:txBody>
+          <a:bodyPr rtlCol="0" anchor="ctr"/>
+          <a:lstStyle/>
+          <a:p>
+            <a:pPr algn="ctr"/>
+          </a:p>
+        </p:txBody>
+      </p:sp>
+      <p:sp>
+        <p:nvSpPr>
+          <p:cNvPr id="40" name="TextBox 39"/>
+          <p:cNvSpPr txBox="1"/>
+          <p:nvPr/>
+        </p:nvSpPr>
+        <p:spPr>
+          <a:xfrm>
+            <a:off x="859536" y="5943600"/>
+            <a:ext cx="6309360" cy="512064"/>
+          </a:xfrm>
+          <a:prstGeom prst="rect">
+            <a:avLst/>
+          </a:prstGeom>
+          <a:noFill/>
+        </p:spPr>
+        <p:txBody>
+          <a:bodyPr wrap="square">
+            <a:spAutoFit/>
+          </a:bodyPr>
+          <a:lstStyle/>
+          <a:p>
+            <a:pPr algn="l">
+              <a:spcAft>
+                <a:spcPts val="100"/>
+              </a:spcAft>
+            </a:pPr>
+            <a:r>
+              <a:rPr sz="1100" b="1">
+                <a:solidFill>
+                  <a:srgbClr val="E8E4DC"/>
+                </a:solidFill>
+                <a:latin typeface="Segoe UI"/>
+              </a:rPr>
+              <a:t>开局那二十秒也是性能问题</a:t>
+            </a:r>
+          </a:p>
+          <a:p>
+            <a:pPr algn="l">
+              <a:spcAft>
+                <a:spcPts val="0"/>
+              </a:spcAft>
+            </a:pPr>
+            <a:r>
+              <a:rPr sz="900" b="0">
+                <a:solidFill>
+                  <a:srgbClr val="9A9488"/>
+                </a:solidFill>
+                <a:latin typeface="Segoe UI"/>
+              </a:rPr>
+              <a:t>画质控制器原本从满分辨率起步，注释自己写着代价是「二十秒的幻灯片」。唯一玩过的人报的正是这个。改成从中间档起步：最坏下降从四步减到两步，快机器一两秒内爬回去。</a:t>
+            </a:r>
+          </a:p>
+        </p:txBody>
+      </p:sp>
+      <p:sp>
+        <p:nvSpPr>
+          <p:cNvPr id="41" name="Rounded Rectangle 40"/>
           <p:cNvSpPr/>
           <p:nvPr/>
         </p:nvSpPr>
@@ -11096,7 +11197,7 @@
       </p:sp>
       <p:sp>
         <p:nvSpPr>
-          <p:cNvPr id="40" name="TextBox 39"/>
+          <p:cNvPr id="42" name="TextBox 41"/>
           <p:cNvSpPr txBox="1"/>
           <p:nvPr/>
         </p:nvSpPr>

</xml_diff>